<commit_message>
submission: refresh update pack with cleaned CN deck + checksums
</commit_message>
<xml_diff>
--- a/submit/update/01_TeaWindow_Pitch_EN.pptx
+++ b/submit/update/01_TeaWindow_Pitch_EN.pptx
@@ -355,7 +355,7 @@
           <a:p>
             <a:fld id="{B7268E1E-0E44-426D-905E-8AD9B19D2182}" type="datetimeFigureOut">
               <a:rPr lang="cs-CZ" smtClean="0"/>
-              <a:t>24.10.2026</a:t>
+              <a:t>17.10.2026</a:t>
             </a:fld>
             <a:endParaRPr lang="cs-CZ"/>
           </a:p>
@@ -1458,8 +1458,8 @@
         </p:nvSpPr>
         <p:spPr>
           <a:xfrm>
-            <a:off x="2293938" y="512763"/>
-            <a:ext cx="4556125" cy="2566987"/>
+            <a:off x="2857500" y="512763"/>
+            <a:ext cx="3429000" cy="2566987"/>
           </a:xfrm>
           <a:prstGeom prst="rect">
             <a:avLst/>
@@ -22170,6 +22170,30 @@
           </a:p>
         </p:txBody>
       </p:sp>
+      <p:pic>
+        <p:nvPicPr>
+          <p:cNvPr id="6" name="Picture 6"/>
+          <p:cNvPicPr>
+            <a:picLocks noChangeAspect="1"/>
+          </p:cNvPicPr>
+          <p:nvPr/>
+        </p:nvPicPr>
+        <p:blipFill>
+          <a:blip r:embed="rId3"/>
+          <a:stretch>
+            <a:fillRect/>
+          </a:stretch>
+        </p:blipFill>
+        <p:spPr>
+          <a:xfrm>
+            <a:off x="10656888" y="6318812"/>
+            <a:ext cx="1522412" cy="539188"/>
+          </a:xfrm>
+          <a:prstGeom prst="rect">
+            <a:avLst/>
+          </a:prstGeom>
+        </p:spPr>
+      </p:pic>
     </p:spTree>
   </p:cSld>
   <p:clrMapOvr>
@@ -22360,7 +22384,7 @@
               <a:defRPr/>
             </a:pPr>
             <a:r>
-              <a:rPr lang="en-US" sz="1600" b="0" i="0" u="none" strike="noStrike" dirty="0">
+              <a:rPr lang="en-US" sz="1600" b="0" i="0" u="none" strike="noStrike">
                 <a:solidFill>
                   <a:srgbClr val="CED9E4"/>
                 </a:solidFill>
@@ -22371,7 +22395,7 @@
               </a:rPr>
               <a:t>• ~70% of gardens grow early-budding, drought-sensitive Longjing 43</a:t>
             </a:r>
-            <a:endParaRPr lang="en-US" sz="1100" dirty="0"/>
+            <a:endParaRPr lang="en-US" sz="1100"/>
           </a:p>
           <a:p>
             <a:pPr marL="0" indent="0" algn="l">
@@ -22380,7 +22404,7 @@
               </a:lnSpc>
             </a:pPr>
             <a:r>
-              <a:rPr lang="en-US" sz="1600" b="0" i="0" u="none" strike="noStrike" dirty="0">
+              <a:rPr lang="en-US" sz="1600" b="0" i="0" u="none" strike="noStrike">
                 <a:solidFill>
                   <a:srgbClr val="CED9E4"/>
                 </a:solidFill>
@@ -22399,7 +22423,7 @@
               </a:lnSpc>
             </a:pPr>
             <a:r>
-              <a:rPr lang="en-US" sz="1600" b="0" i="0" u="none" strike="noStrike" dirty="0">
+              <a:rPr lang="en-US" sz="1600" b="0" i="0" u="none" strike="noStrike">
                 <a:solidFill>
                   <a:srgbClr val="CED9E4"/>
                 </a:solidFill>

</xml_diff>

<commit_message>
submission: 13-page decks (arch merged) + WeChat-friendly PDFs + one video
</commit_message>
<xml_diff>
--- a/submit/update/01_TeaWindow_Pitch_EN.pptx
+++ b/submit/update/01_TeaWindow_Pitch_EN.pptx
@@ -22,6 +22,7 @@
     <p:sldId id="265" r:id="rId13"/>
     <p:sldId id="266" r:id="rId14"/>
     <p:sldId id="267" r:id="rId15"/>
+    <p:sldId id="268" r:id="rId21"/>
   </p:sldIdLst>
   <p:sldSz cx="12179300" cy="6858000"/>
   <p:notesSz cx="6858000" cy="9144000"/>
@@ -22202,6 +22203,48 @@
 </p:sld>
 </file>
 
+<file path=ppt/slides/slide13.xml><?xml version="1.0" encoding="utf-8"?>
+<p:sld xmlns:a="http://schemas.openxmlformats.org/drawingml/2006/main" xmlns:p="http://schemas.openxmlformats.org/presentationml/2006/main" xmlns:r="http://schemas.openxmlformats.org/officeDocument/2006/relationships">
+  <p:cSld>
+    <p:spTree>
+      <p:nvGrpSpPr>
+        <p:cNvPr id="1" name=""/>
+        <p:cNvGrpSpPr/>
+        <p:nvPr/>
+      </p:nvGrpSpPr>
+      <p:grpSpPr/>
+      <p:pic>
+        <p:nvPicPr>
+          <p:cNvPr id="2" name="Picture 1" descr="30_architecture_1plus5_EN.png"/>
+          <p:cNvPicPr>
+            <a:picLocks noChangeAspect="1"/>
+          </p:cNvPicPr>
+          <p:nvPr/>
+        </p:nvPicPr>
+        <p:blipFill>
+          <a:blip r:embed="rId2"/>
+          <a:stretch>
+            <a:fillRect/>
+          </a:stretch>
+        </p:blipFill>
+        <p:spPr>
+          <a:xfrm>
+            <a:off x="0" y="0"/>
+            <a:ext cx="12179300" cy="6858000"/>
+          </a:xfrm>
+          <a:prstGeom prst="rect">
+            <a:avLst/>
+          </a:prstGeom>
+        </p:spPr>
+      </p:pic>
+    </p:spTree>
+  </p:cSld>
+  <p:clrMapOvr>
+    <a:masterClrMapping/>
+  </p:clrMapOvr>
+</p:sld>
+</file>
+
 <file path=ppt/slides/slide2.xml><?xml version="1.0" encoding="utf-8"?>
 <p:sld xmlns:a="http://schemas.openxmlformats.org/drawingml/2006/main" xmlns:r="http://schemas.openxmlformats.org/officeDocument/2006/relationships" xmlns:p="http://schemas.openxmlformats.org/presentationml/2006/main">
   <p:cSld>

</xml_diff>

<commit_message>
deck: add team slide (page 2) with application fields; 14-page decks + PDFs; refresh pack
</commit_message>
<xml_diff>
--- a/submit/update/01_TeaWindow_Pitch_EN.pptx
+++ b/submit/update/01_TeaWindow_Pitch_EN.pptx
@@ -11,6 +11,7 @@
   </p:notesMasterIdLst>
   <p:sldIdLst>
     <p:sldId id="256" r:id="rId4"/>
+    <p:sldId id="269" r:id="rId22"/>
     <p:sldId id="257" r:id="rId5"/>
     <p:sldId id="258" r:id="rId6"/>
     <p:sldId id="259" r:id="rId7"/>
@@ -22245,6 +22246,718 @@
 </p:sld>
 </file>
 
+<file path=ppt/slides/slide14.xml><?xml version="1.0" encoding="utf-8"?>
+<p:sld xmlns:a="http://schemas.openxmlformats.org/drawingml/2006/main" xmlns:p="http://schemas.openxmlformats.org/presentationml/2006/main" xmlns:r="http://schemas.openxmlformats.org/officeDocument/2006/relationships">
+  <p:cSld>
+    <p:spTree>
+      <p:nvGrpSpPr>
+        <p:cNvPr id="1" name=""/>
+        <p:cNvGrpSpPr/>
+        <p:nvPr/>
+      </p:nvGrpSpPr>
+      <p:grpSpPr/>
+      <p:sp>
+        <p:nvSpPr>
+          <p:cNvPr id="2" name="Rectangle 1"/>
+          <p:cNvSpPr/>
+          <p:nvPr/>
+        </p:nvSpPr>
+        <p:spPr>
+          <a:xfrm>
+            <a:off x="0" y="0"/>
+            <a:ext cx="12179808" cy="6858000"/>
+          </a:xfrm>
+          <a:prstGeom prst="rect">
+            <a:avLst/>
+          </a:prstGeom>
+          <a:solidFill>
+            <a:srgbClr val="0F1720"/>
+          </a:solidFill>
+          <a:ln>
+            <a:noFill/>
+          </a:ln>
+          <a:effectLst/>
+        </p:spPr>
+        <p:style>
+          <a:lnRef idx="1">
+            <a:schemeClr val="accent1"/>
+          </a:lnRef>
+          <a:fillRef idx="3">
+            <a:schemeClr val="accent1"/>
+          </a:fillRef>
+          <a:effectRef idx="2">
+            <a:schemeClr val="accent1"/>
+          </a:effectRef>
+          <a:fontRef idx="minor">
+            <a:schemeClr val="lt1"/>
+          </a:fontRef>
+        </p:style>
+        <p:txBody>
+          <a:bodyPr rtlCol="0" anchor="ctr"/>
+          <a:lstStyle/>
+          <a:p>
+            <a:pPr algn="ctr"/>
+          </a:p>
+        </p:txBody>
+      </p:sp>
+      <p:sp>
+        <p:nvSpPr>
+          <p:cNvPr id="3" name="Rectangle 2"/>
+          <p:cNvSpPr/>
+          <p:nvPr/>
+        </p:nvSpPr>
+        <p:spPr>
+          <a:xfrm>
+            <a:off x="640080" y="658368"/>
+            <a:ext cx="64008" cy="777240"/>
+          </a:xfrm>
+          <a:prstGeom prst="rect">
+            <a:avLst/>
+          </a:prstGeom>
+          <a:solidFill>
+            <a:srgbClr val="4AA8FF"/>
+          </a:solidFill>
+          <a:ln>
+            <a:noFill/>
+          </a:ln>
+          <a:effectLst/>
+        </p:spPr>
+        <p:style>
+          <a:lnRef idx="1">
+            <a:schemeClr val="accent1"/>
+          </a:lnRef>
+          <a:fillRef idx="3">
+            <a:schemeClr val="accent1"/>
+          </a:fillRef>
+          <a:effectRef idx="2">
+            <a:schemeClr val="accent1"/>
+          </a:effectRef>
+          <a:fontRef idx="minor">
+            <a:schemeClr val="lt1"/>
+          </a:fontRef>
+        </p:style>
+        <p:txBody>
+          <a:bodyPr rtlCol="0" anchor="ctr"/>
+          <a:lstStyle/>
+          <a:p>
+            <a:pPr algn="ctr"/>
+          </a:p>
+        </p:txBody>
+      </p:sp>
+      <p:sp>
+        <p:nvSpPr>
+          <p:cNvPr id="4" name="TextBox 3"/>
+          <p:cNvSpPr txBox="1"/>
+          <p:nvPr/>
+        </p:nvSpPr>
+        <p:spPr>
+          <a:xfrm>
+            <a:off x="868680" y="621792"/>
+            <a:ext cx="8229600" cy="640080"/>
+          </a:xfrm>
+          <a:prstGeom prst="rect">
+            <a:avLst/>
+          </a:prstGeom>
+          <a:noFill/>
+        </p:spPr>
+        <p:txBody>
+          <a:bodyPr wrap="square">
+            <a:spAutoFit/>
+          </a:bodyPr>
+          <a:lstStyle/>
+          <a:p>
+            <a:pPr algn="l"/>
+            <a:r>
+              <a:rPr sz="3000" b="1" i="0">
+                <a:solidFill>
+                  <a:srgbClr val="E8EEF3"/>
+                </a:solidFill>
+                <a:latin typeface="Montserrat"/>
+              </a:rPr>
+              <a:t>Team &amp; background</a:t>
+            </a:r>
+          </a:p>
+        </p:txBody>
+      </p:sp>
+      <p:sp>
+        <p:nvSpPr>
+          <p:cNvPr id="5" name="TextBox 4"/>
+          <p:cNvSpPr txBox="1"/>
+          <p:nvPr/>
+        </p:nvSpPr>
+        <p:spPr>
+          <a:xfrm>
+            <a:off x="868680" y="1481328"/>
+            <a:ext cx="5486400" cy="731520"/>
+          </a:xfrm>
+          <a:prstGeom prst="rect">
+            <a:avLst/>
+          </a:prstGeom>
+          <a:noFill/>
+        </p:spPr>
+        <p:txBody>
+          <a:bodyPr wrap="square">
+            <a:spAutoFit/>
+          </a:bodyPr>
+          <a:lstStyle/>
+          <a:p>
+            <a:pPr algn="l"/>
+            <a:r>
+              <a:rPr sz="4000" b="1" i="0">
+                <a:solidFill>
+                  <a:srgbClr val="E8EEF3"/>
+                </a:solidFill>
+                <a:latin typeface="Montserrat"/>
+              </a:rPr>
+              <a:t>Ye Zixuan</a:t>
+            </a:r>
+          </a:p>
+        </p:txBody>
+      </p:sp>
+      <p:sp>
+        <p:nvSpPr>
+          <p:cNvPr id="6" name="TextBox 5"/>
+          <p:cNvSpPr txBox="1"/>
+          <p:nvPr/>
+        </p:nvSpPr>
+        <p:spPr>
+          <a:xfrm>
+            <a:off x="868680" y="2148840"/>
+            <a:ext cx="5486400" cy="365760"/>
+          </a:xfrm>
+          <a:prstGeom prst="rect">
+            <a:avLst/>
+          </a:prstGeom>
+          <a:noFill/>
+        </p:spPr>
+        <p:txBody>
+          <a:bodyPr wrap="square">
+            <a:spAutoFit/>
+          </a:bodyPr>
+          <a:lstStyle/>
+          <a:p>
+            <a:pPr algn="l"/>
+            <a:r>
+              <a:rPr sz="1800" b="0" i="0">
+                <a:solidFill>
+                  <a:srgbClr val="9FB4C6"/>
+                </a:solidFill>
+                <a:latin typeface="Montserrat"/>
+              </a:rPr>
+              <a:t>叶子玄</a:t>
+            </a:r>
+          </a:p>
+        </p:txBody>
+      </p:sp>
+      <p:sp>
+        <p:nvSpPr>
+          <p:cNvPr id="7" name="TextBox 6"/>
+          <p:cNvSpPr txBox="1"/>
+          <p:nvPr/>
+        </p:nvSpPr>
+        <p:spPr>
+          <a:xfrm>
+            <a:off x="868680" y="2606040"/>
+            <a:ext cx="5669280" cy="457200"/>
+          </a:xfrm>
+          <a:prstGeom prst="rect">
+            <a:avLst/>
+          </a:prstGeom>
+          <a:noFill/>
+        </p:spPr>
+        <p:txBody>
+          <a:bodyPr wrap="square">
+            <a:spAutoFit/>
+          </a:bodyPr>
+          <a:lstStyle/>
+          <a:p>
+            <a:pPr algn="l"/>
+            <a:r>
+              <a:rPr sz="1600" b="0" i="0">
+                <a:solidFill>
+                  <a:srgbClr val="CED9E4"/>
+                </a:solidFill>
+                <a:latin typeface="Inter"/>
+              </a:rPr>
+              <a:t>Zhejiang University · Computer Science and Technology (BSc, Year 2)</a:t>
+            </a:r>
+          </a:p>
+        </p:txBody>
+      </p:sp>
+      <p:sp>
+        <p:nvSpPr>
+          <p:cNvPr id="8" name="TextBox 7"/>
+          <p:cNvSpPr txBox="1"/>
+          <p:nvPr/>
+        </p:nvSpPr>
+        <p:spPr>
+          <a:xfrm>
+            <a:off x="868680" y="3200400"/>
+            <a:ext cx="5669280" cy="365760"/>
+          </a:xfrm>
+          <a:prstGeom prst="rect">
+            <a:avLst/>
+          </a:prstGeom>
+          <a:noFill/>
+        </p:spPr>
+        <p:txBody>
+          <a:bodyPr wrap="square">
+            <a:spAutoFit/>
+          </a:bodyPr>
+          <a:lstStyle/>
+          <a:p>
+            <a:pPr algn="l"/>
+            <a:r>
+              <a:rPr sz="1350" b="0" i="0">
+                <a:solidFill>
+                  <a:srgbClr val="CED9E4"/>
+                </a:solidFill>
+                <a:latin typeface="Inter"/>
+              </a:rPr>
+              <a:t>Role: project lead · algorithms &amp; full-stack</a:t>
+            </a:r>
+          </a:p>
+        </p:txBody>
+      </p:sp>
+      <p:sp>
+        <p:nvSpPr>
+          <p:cNvPr id="9" name="TextBox 8"/>
+          <p:cNvSpPr txBox="1"/>
+          <p:nvPr/>
+        </p:nvSpPr>
+        <p:spPr>
+          <a:xfrm>
+            <a:off x="868680" y="3538728"/>
+            <a:ext cx="5669280" cy="365760"/>
+          </a:xfrm>
+          <a:prstGeom prst="rect">
+            <a:avLst/>
+          </a:prstGeom>
+          <a:noFill/>
+        </p:spPr>
+        <p:txBody>
+          <a:bodyPr wrap="square">
+            <a:spAutoFit/>
+          </a:bodyPr>
+          <a:lstStyle/>
+          <a:p>
+            <a:pPr algn="l"/>
+            <a:r>
+              <a:rPr sz="1350" b="0" i="0">
+                <a:solidFill>
+                  <a:srgbClr val="CED9E4"/>
+                </a:solidFill>
+                <a:latin typeface="Inter"/>
+              </a:rPr>
+              <a:t>Team: solo (1 person) · age 19</a:t>
+            </a:r>
+          </a:p>
+        </p:txBody>
+      </p:sp>
+      <p:sp>
+        <p:nvSpPr>
+          <p:cNvPr id="10" name="TextBox 9"/>
+          <p:cNvSpPr txBox="1"/>
+          <p:nvPr/>
+        </p:nvSpPr>
+        <p:spPr>
+          <a:xfrm>
+            <a:off x="868680" y="3877056"/>
+            <a:ext cx="5669280" cy="365760"/>
+          </a:xfrm>
+          <a:prstGeom prst="rect">
+            <a:avLst/>
+          </a:prstGeom>
+          <a:noFill/>
+        </p:spPr>
+        <p:txBody>
+          <a:bodyPr wrap="square">
+            <a:spAutoFit/>
+          </a:bodyPr>
+          <a:lstStyle/>
+          <a:p>
+            <a:pPr algn="l"/>
+            <a:r>
+              <a:rPr sz="1350" b="0" i="0">
+                <a:solidFill>
+                  <a:srgbClr val="CED9E4"/>
+                </a:solidFill>
+                <a:latin typeface="Inter"/>
+              </a:rPr>
+              <a:t>Location: Hangzhou, China</a:t>
+            </a:r>
+          </a:p>
+        </p:txBody>
+      </p:sp>
+      <p:sp>
+        <p:nvSpPr>
+          <p:cNvPr id="11" name="TextBox 10"/>
+          <p:cNvSpPr txBox="1"/>
+          <p:nvPr/>
+        </p:nvSpPr>
+        <p:spPr>
+          <a:xfrm>
+            <a:off x="868680" y="4215384"/>
+            <a:ext cx="5669280" cy="365760"/>
+          </a:xfrm>
+          <a:prstGeom prst="rect">
+            <a:avLst/>
+          </a:prstGeom>
+          <a:noFill/>
+        </p:spPr>
+        <p:txBody>
+          <a:bodyPr wrap="square">
+            <a:spAutoFit/>
+          </a:bodyPr>
+          <a:lstStyle/>
+          <a:p>
+            <a:pPr algn="l"/>
+            <a:r>
+              <a:rPr sz="1350" b="0" i="0">
+                <a:solidFill>
+                  <a:srgbClr val="CED9E4"/>
+                </a:solidFill>
+                <a:latin typeface="Inter"/>
+              </a:rPr>
+              <a:t>Phone: +86 15858238044</a:t>
+            </a:r>
+          </a:p>
+        </p:txBody>
+      </p:sp>
+      <p:sp>
+        <p:nvSpPr>
+          <p:cNvPr id="12" name="TextBox 11"/>
+          <p:cNvSpPr txBox="1"/>
+          <p:nvPr/>
+        </p:nvSpPr>
+        <p:spPr>
+          <a:xfrm>
+            <a:off x="868680" y="4553712"/>
+            <a:ext cx="5669280" cy="365760"/>
+          </a:xfrm>
+          <a:prstGeom prst="rect">
+            <a:avLst/>
+          </a:prstGeom>
+          <a:noFill/>
+        </p:spPr>
+        <p:txBody>
+          <a:bodyPr wrap="square">
+            <a:spAutoFit/>
+          </a:bodyPr>
+          <a:lstStyle/>
+          <a:p>
+            <a:pPr algn="l"/>
+            <a:r>
+              <a:rPr sz="1350" b="0" i="0">
+                <a:solidFill>
+                  <a:srgbClr val="CED9E4"/>
+                </a:solidFill>
+                <a:latin typeface="Inter"/>
+              </a:rPr>
+              <a:t>Email: 2302372846@qq.com</a:t>
+            </a:r>
+          </a:p>
+        </p:txBody>
+      </p:sp>
+      <p:sp>
+        <p:nvSpPr>
+          <p:cNvPr id="13" name="TextBox 12"/>
+          <p:cNvSpPr txBox="1"/>
+          <p:nvPr/>
+        </p:nvSpPr>
+        <p:spPr>
+          <a:xfrm>
+            <a:off x="868680" y="4892040"/>
+            <a:ext cx="5669280" cy="365760"/>
+          </a:xfrm>
+          <a:prstGeom prst="rect">
+            <a:avLst/>
+          </a:prstGeom>
+          <a:noFill/>
+        </p:spPr>
+        <p:txBody>
+          <a:bodyPr wrap="square">
+            <a:spAutoFit/>
+          </a:bodyPr>
+          <a:lstStyle/>
+          <a:p>
+            <a:pPr algn="l"/>
+            <a:r>
+              <a:rPr sz="1350" b="0" i="0">
+                <a:solidFill>
+                  <a:srgbClr val="CED9E4"/>
+                </a:solidFill>
+                <a:latin typeface="Inter"/>
+              </a:rPr>
+              <a:t>Track: 01 · Climate-smart tea farming in Meijiawu</a:t>
+            </a:r>
+          </a:p>
+        </p:txBody>
+      </p:sp>
+      <p:sp>
+        <p:nvSpPr>
+          <p:cNvPr id="14" name="Rectangle 13"/>
+          <p:cNvSpPr/>
+          <p:nvPr/>
+        </p:nvSpPr>
+        <p:spPr>
+          <a:xfrm>
+            <a:off x="6720840" y="1481328"/>
+            <a:ext cx="4800600" cy="3246120"/>
+          </a:xfrm>
+          <a:prstGeom prst="rect">
+            <a:avLst/>
+          </a:prstGeom>
+          <a:solidFill>
+            <a:srgbClr val="16212B"/>
+          </a:solidFill>
+          <a:ln w="9525">
+            <a:solidFill>
+              <a:srgbClr val="2B3D4D"/>
+            </a:solidFill>
+          </a:ln>
+          <a:effectLst/>
+        </p:spPr>
+        <p:style>
+          <a:lnRef idx="1">
+            <a:schemeClr val="accent1"/>
+          </a:lnRef>
+          <a:fillRef idx="3">
+            <a:schemeClr val="accent1"/>
+          </a:fillRef>
+          <a:effectRef idx="2">
+            <a:schemeClr val="accent1"/>
+          </a:effectRef>
+          <a:fontRef idx="minor">
+            <a:schemeClr val="lt1"/>
+          </a:fontRef>
+        </p:style>
+        <p:txBody>
+          <a:bodyPr rtlCol="0" anchor="ctr"/>
+          <a:lstStyle/>
+          <a:p>
+            <a:pPr algn="ctr"/>
+          </a:p>
+        </p:txBody>
+      </p:sp>
+      <p:sp>
+        <p:nvSpPr>
+          <p:cNvPr id="15" name="TextBox 14"/>
+          <p:cNvSpPr txBox="1"/>
+          <p:nvPr/>
+        </p:nvSpPr>
+        <p:spPr>
+          <a:xfrm>
+            <a:off x="6967728" y="1664208"/>
+            <a:ext cx="4389120" cy="365760"/>
+          </a:xfrm>
+          <a:prstGeom prst="rect">
+            <a:avLst/>
+          </a:prstGeom>
+          <a:noFill/>
+        </p:spPr>
+        <p:txBody>
+          <a:bodyPr wrap="square">
+            <a:spAutoFit/>
+          </a:bodyPr>
+          <a:lstStyle/>
+          <a:p>
+            <a:pPr algn="l"/>
+            <a:r>
+              <a:rPr sz="1600" b="1" i="0">
+                <a:solidFill>
+                  <a:srgbClr val="4AA8FF"/>
+                </a:solidFill>
+                <a:latin typeface="Inter"/>
+              </a:rPr>
+              <a:t>What I built</a:t>
+            </a:r>
+          </a:p>
+        </p:txBody>
+      </p:sp>
+      <p:sp>
+        <p:nvSpPr>
+          <p:cNvPr id="16" name="TextBox 15"/>
+          <p:cNvSpPr txBox="1"/>
+          <p:nvPr/>
+        </p:nvSpPr>
+        <p:spPr>
+          <a:xfrm>
+            <a:off x="6967728" y="2148840"/>
+            <a:ext cx="4343400" cy="777240"/>
+          </a:xfrm>
+          <a:prstGeom prst="rect">
+            <a:avLst/>
+          </a:prstGeom>
+          <a:noFill/>
+        </p:spPr>
+        <p:txBody>
+          <a:bodyPr wrap="square">
+            <a:spAutoFit/>
+          </a:bodyPr>
+          <a:lstStyle/>
+          <a:p>
+            <a:pPr algn="l"/>
+            <a:r>
+              <a:rPr sz="1250" b="0" i="0">
+                <a:solidFill>
+                  <a:srgbClr val="CED9E4"/>
+                </a:solidFill>
+                <a:latin typeface="Inter"/>
+              </a:rPr>
+              <a:t>• Data: ERA5 + MET Norway, Sentinel-2, 30 m DEM downscaling</a:t>
+            </a:r>
+          </a:p>
+        </p:txBody>
+      </p:sp>
+      <p:sp>
+        <p:nvSpPr>
+          <p:cNvPr id="17" name="TextBox 16"/>
+          <p:cNvSpPr txBox="1"/>
+          <p:nvPr/>
+        </p:nvSpPr>
+        <p:spPr>
+          <a:xfrm>
+            <a:off x="6967728" y="2971800"/>
+            <a:ext cx="4343400" cy="777240"/>
+          </a:xfrm>
+          <a:prstGeom prst="rect">
+            <a:avLst/>
+          </a:prstGeom>
+          <a:noFill/>
+        </p:spPr>
+        <p:txBody>
+          <a:bodyPr wrap="square">
+            <a:spAutoFit/>
+          </a:bodyPr>
+          <a:lstStyle/>
+          <a:p>
+            <a:pPr algn="l"/>
+            <a:r>
+              <a:rPr sz="1250" b="0" i="0">
+                <a:solidFill>
+                  <a:srgbClr val="CED9E4"/>
+                </a:solidFill>
+                <a:latin typeface="Inter"/>
+              </a:rPr>
+              <a:t>• Model: numpy GBDT compound risk; frozen eval set; picking-date MAE 1.8 d</a:t>
+            </a:r>
+          </a:p>
+        </p:txBody>
+      </p:sp>
+      <p:sp>
+        <p:nvSpPr>
+          <p:cNvPr id="18" name="TextBox 17"/>
+          <p:cNvSpPr txBox="1"/>
+          <p:nvPr/>
+        </p:nvSpPr>
+        <p:spPr>
+          <a:xfrm>
+            <a:off x="6967728" y="3794760"/>
+            <a:ext cx="4343400" cy="777240"/>
+          </a:xfrm>
+          <a:prstGeom prst="rect">
+            <a:avLst/>
+          </a:prstGeom>
+          <a:noFill/>
+        </p:spPr>
+        <p:txBody>
+          <a:bodyPr wrap="square">
+            <a:spAutoFit/>
+          </a:bodyPr>
+          <a:lstStyle/>
+          <a:p>
+            <a:pPr algn="l"/>
+            <a:r>
+              <a:rPr sz="1250" b="0" i="0">
+                <a:solidFill>
+                  <a:srgbClr val="CED9E4"/>
+                </a:solidFill>
+                <a:latin typeface="Inter"/>
+              </a:rPr>
+              <a:t>• Product: live demo, terrain risk map, grounded Q&amp;A with the 1+5 gate, deployment</a:t>
+            </a:r>
+          </a:p>
+        </p:txBody>
+      </p:sp>
+      <p:sp>
+        <p:nvSpPr>
+          <p:cNvPr id="19" name="TextBox 18"/>
+          <p:cNvSpPr txBox="1"/>
+          <p:nvPr/>
+        </p:nvSpPr>
+        <p:spPr>
+          <a:xfrm>
+            <a:off x="868680" y="5257800"/>
+            <a:ext cx="10607040" cy="457200"/>
+          </a:xfrm>
+          <a:prstGeom prst="rect">
+            <a:avLst/>
+          </a:prstGeom>
+          <a:noFill/>
+        </p:spPr>
+        <p:txBody>
+          <a:bodyPr wrap="square">
+            <a:spAutoFit/>
+          </a:bodyPr>
+          <a:lstStyle/>
+          <a:p>
+            <a:pPr algn="l"/>
+            <a:r>
+              <a:rPr sz="1800" b="0" i="1">
+                <a:solidFill>
+                  <a:srgbClr val="E8EEF3"/>
+                </a:solidFill>
+                <a:latin typeface="Inter"/>
+              </a:rPr>
+              <a:t>Turning climate data into an action a tea farmer can take today.</a:t>
+            </a:r>
+          </a:p>
+        </p:txBody>
+      </p:sp>
+      <p:sp>
+        <p:nvSpPr>
+          <p:cNvPr id="20" name="TextBox 19"/>
+          <p:cNvSpPr txBox="1"/>
+          <p:nvPr/>
+        </p:nvSpPr>
+        <p:spPr>
+          <a:xfrm>
+            <a:off x="868680" y="5989320"/>
+            <a:ext cx="10607040" cy="365760"/>
+          </a:xfrm>
+          <a:prstGeom prst="rect">
+            <a:avLst/>
+          </a:prstGeom>
+          <a:noFill/>
+        </p:spPr>
+        <p:txBody>
+          <a:bodyPr wrap="square">
+            <a:spAutoFit/>
+          </a:bodyPr>
+          <a:lstStyle/>
+          <a:p>
+            <a:pPr algn="l"/>
+            <a:r>
+              <a:rPr sz="1050" b="0" i="0">
+                <a:solidFill>
+                  <a:srgbClr val="9FB4C6"/>
+                </a:solidFill>
+                <a:latin typeface="Inter"/>
+              </a:rPr>
+              <a:t>Demo: teawindow.onrender.com | Repo: github.com/Eric2007-sudo/TeaWindow | Stage: prototype / demo available</a:t>
+            </a:r>
+          </a:p>
+        </p:txBody>
+      </p:sp>
+    </p:spTree>
+  </p:cSld>
+  <p:clrMapOvr>
+    <a:masterClrMapping/>
+  </p:clrMapOvr>
+</p:sld>
+</file>
+
 <file path=ppt/slides/slide2.xml><?xml version="1.0" encoding="utf-8"?>
 <p:sld xmlns:a="http://schemas.openxmlformats.org/drawingml/2006/main" xmlns:r="http://schemas.openxmlformats.org/officeDocument/2006/relationships" xmlns:p="http://schemas.openxmlformats.org/presentationml/2006/main">
   <p:cSld>

</xml_diff>